<commit_message>
Update Frequency Encoding presentation file
</commit_message>
<xml_diff>
--- a/My Note and Practice/Text to Numerical Data Conversion/Categorical(Text to Numeric) data conversion-CTtN/Nominal Data/CTNtN4. Frequency Encoding/Frequency Encoding.pptx
+++ b/My Note and Practice/Text to Numerical Data Conversion/Categorical(Text to Numeric) data conversion-CTtN/Nominal Data/CTNtN4. Frequency Encoding/Frequency Encoding.pptx
@@ -5,13 +5,14 @@
     <p:sldMasterId id="2147483648" r:id="rId1"/>
   </p:sldMasterIdLst>
   <p:sldIdLst>
-    <p:sldId id="322" r:id="rId2"/>
-    <p:sldId id="329" r:id="rId3"/>
-    <p:sldId id="323" r:id="rId4"/>
-    <p:sldId id="325" r:id="rId5"/>
-    <p:sldId id="326" r:id="rId6"/>
-    <p:sldId id="327" r:id="rId7"/>
-    <p:sldId id="328" r:id="rId8"/>
+    <p:sldId id="330" r:id="rId2"/>
+    <p:sldId id="322" r:id="rId3"/>
+    <p:sldId id="329" r:id="rId4"/>
+    <p:sldId id="323" r:id="rId5"/>
+    <p:sldId id="325" r:id="rId6"/>
+    <p:sldId id="326" r:id="rId7"/>
+    <p:sldId id="327" r:id="rId8"/>
+    <p:sldId id="328" r:id="rId9"/>
   </p:sldIdLst>
   <p:sldSz cx="12192000" cy="6858000"/>
   <p:notesSz cx="6858000" cy="9144000"/>
@@ -265,7 +266,7 @@
           <a:p>
             <a:fld id="{A118E0CD-D5B0-494C-BE6F-3BCCEAD59C46}" type="datetimeFigureOut">
               <a:rPr lang="en-US" smtClean="0"/>
-              <a:t>11/17/2025</a:t>
+              <a:t>11/22/2025</a:t>
             </a:fld>
             <a:endParaRPr lang="en-US"/>
           </a:p>
@@ -463,7 +464,7 @@
           <a:p>
             <a:fld id="{A118E0CD-D5B0-494C-BE6F-3BCCEAD59C46}" type="datetimeFigureOut">
               <a:rPr lang="en-US" smtClean="0"/>
-              <a:t>11/17/2025</a:t>
+              <a:t>11/22/2025</a:t>
             </a:fld>
             <a:endParaRPr lang="en-US"/>
           </a:p>
@@ -671,7 +672,7 @@
           <a:p>
             <a:fld id="{A118E0CD-D5B0-494C-BE6F-3BCCEAD59C46}" type="datetimeFigureOut">
               <a:rPr lang="en-US" smtClean="0"/>
-              <a:t>11/17/2025</a:t>
+              <a:t>11/22/2025</a:t>
             </a:fld>
             <a:endParaRPr lang="en-US"/>
           </a:p>
@@ -869,7 +870,7 @@
           <a:p>
             <a:fld id="{A118E0CD-D5B0-494C-BE6F-3BCCEAD59C46}" type="datetimeFigureOut">
               <a:rPr lang="en-US" smtClean="0"/>
-              <a:t>11/17/2025</a:t>
+              <a:t>11/22/2025</a:t>
             </a:fld>
             <a:endParaRPr lang="en-US"/>
           </a:p>
@@ -1144,7 +1145,7 @@
           <a:p>
             <a:fld id="{A118E0CD-D5B0-494C-BE6F-3BCCEAD59C46}" type="datetimeFigureOut">
               <a:rPr lang="en-US" smtClean="0"/>
-              <a:t>11/17/2025</a:t>
+              <a:t>11/22/2025</a:t>
             </a:fld>
             <a:endParaRPr lang="en-US"/>
           </a:p>
@@ -1409,7 +1410,7 @@
           <a:p>
             <a:fld id="{A118E0CD-D5B0-494C-BE6F-3BCCEAD59C46}" type="datetimeFigureOut">
               <a:rPr lang="en-US" smtClean="0"/>
-              <a:t>11/17/2025</a:t>
+              <a:t>11/22/2025</a:t>
             </a:fld>
             <a:endParaRPr lang="en-US"/>
           </a:p>
@@ -1821,7 +1822,7 @@
           <a:p>
             <a:fld id="{A118E0CD-D5B0-494C-BE6F-3BCCEAD59C46}" type="datetimeFigureOut">
               <a:rPr lang="en-US" smtClean="0"/>
-              <a:t>11/17/2025</a:t>
+              <a:t>11/22/2025</a:t>
             </a:fld>
             <a:endParaRPr lang="en-US"/>
           </a:p>
@@ -1962,7 +1963,7 @@
           <a:p>
             <a:fld id="{A118E0CD-D5B0-494C-BE6F-3BCCEAD59C46}" type="datetimeFigureOut">
               <a:rPr lang="en-US" smtClean="0"/>
-              <a:t>11/17/2025</a:t>
+              <a:t>11/22/2025</a:t>
             </a:fld>
             <a:endParaRPr lang="en-US"/>
           </a:p>
@@ -2075,7 +2076,7 @@
           <a:p>
             <a:fld id="{A118E0CD-D5B0-494C-BE6F-3BCCEAD59C46}" type="datetimeFigureOut">
               <a:rPr lang="en-US" smtClean="0"/>
-              <a:t>11/17/2025</a:t>
+              <a:t>11/22/2025</a:t>
             </a:fld>
             <a:endParaRPr lang="en-US"/>
           </a:p>
@@ -2386,7 +2387,7 @@
           <a:p>
             <a:fld id="{A118E0CD-D5B0-494C-BE6F-3BCCEAD59C46}" type="datetimeFigureOut">
               <a:rPr lang="en-US" smtClean="0"/>
-              <a:t>11/17/2025</a:t>
+              <a:t>11/22/2025</a:t>
             </a:fld>
             <a:endParaRPr lang="en-US"/>
           </a:p>
@@ -2674,7 +2675,7 @@
           <a:p>
             <a:fld id="{A118E0CD-D5B0-494C-BE6F-3BCCEAD59C46}" type="datetimeFigureOut">
               <a:rPr lang="en-US" smtClean="0"/>
-              <a:t>11/17/2025</a:t>
+              <a:t>11/22/2025</a:t>
             </a:fld>
             <a:endParaRPr lang="en-US"/>
           </a:p>
@@ -2915,7 +2916,7 @@
           <a:p>
             <a:fld id="{A118E0CD-D5B0-494C-BE6F-3BCCEAD59C46}" type="datetimeFigureOut">
               <a:rPr lang="en-US" smtClean="0"/>
-              <a:t>11/17/2025</a:t>
+              <a:t>11/22/2025</a:t>
             </a:fld>
             <a:endParaRPr lang="en-US"/>
           </a:p>
@@ -3316,6 +3317,115 @@
 </file>
 
 <file path=ppt/slides/slide1.xml><?xml version="1.0" encoding="utf-8"?>
+<p:sld xmlns:a="http://schemas.openxmlformats.org/drawingml/2006/main" xmlns:r="http://schemas.openxmlformats.org/officeDocument/2006/relationships" xmlns:p="http://schemas.openxmlformats.org/presentationml/2006/main">
+  <p:cSld>
+    <p:spTree>
+      <p:nvGrpSpPr>
+        <p:cNvPr id="1" name=""/>
+        <p:cNvGrpSpPr/>
+        <p:nvPr/>
+      </p:nvGrpSpPr>
+      <p:grpSpPr>
+        <a:xfrm>
+          <a:off x="0" y="0"/>
+          <a:ext cx="0" cy="0"/>
+          <a:chOff x="0" y="0"/>
+          <a:chExt cx="0" cy="0"/>
+        </a:xfrm>
+      </p:grpSpPr>
+      <p:sp>
+        <p:nvSpPr>
+          <p:cNvPr id="2" name="Title 1">
+            <a:extLst>
+              <a:ext uri="{FF2B5EF4-FFF2-40B4-BE49-F238E27FC236}">
+                <a16:creationId xmlns:a16="http://schemas.microsoft.com/office/drawing/2014/main" id="{F40F9490-6727-EA52-8BFA-A24D3883AD7A}"/>
+              </a:ext>
+            </a:extLst>
+          </p:cNvPr>
+          <p:cNvSpPr>
+            <a:spLocks noGrp="1"/>
+          </p:cNvSpPr>
+          <p:nvPr>
+            <p:ph type="ctrTitle"/>
+          </p:nvPr>
+        </p:nvSpPr>
+        <p:spPr/>
+        <p:txBody>
+          <a:bodyPr>
+            <a:normAutofit/>
+          </a:bodyPr>
+          <a:lstStyle/>
+          <a:p>
+            <a:r>
+              <a:rPr lang="en-US" sz="7000" dirty="0">
+                <a:latin typeface="Bebas Neue" panose="020B0606020202050201" pitchFamily="34" charset="0"/>
+              </a:rPr>
+              <a:t>Frequency Encoding in Machine Learning</a:t>
+            </a:r>
+          </a:p>
+        </p:txBody>
+      </p:sp>
+      <p:sp>
+        <p:nvSpPr>
+          <p:cNvPr id="3" name="Subtitle 2">
+            <a:extLst>
+              <a:ext uri="{FF2B5EF4-FFF2-40B4-BE49-F238E27FC236}">
+                <a16:creationId xmlns:a16="http://schemas.microsoft.com/office/drawing/2014/main" id="{682AB7E5-318C-D3F0-75D1-D4D85D288FB5}"/>
+              </a:ext>
+            </a:extLst>
+          </p:cNvPr>
+          <p:cNvSpPr>
+            <a:spLocks noGrp="1"/>
+          </p:cNvSpPr>
+          <p:nvPr>
+            <p:ph type="subTitle" idx="1"/>
+          </p:nvPr>
+        </p:nvSpPr>
+        <p:spPr/>
+        <p:txBody>
+          <a:bodyPr>
+            <a:normAutofit/>
+          </a:bodyPr>
+          <a:lstStyle/>
+          <a:p>
+            <a:r>
+              <a:rPr lang="en-US" sz="3200" dirty="0">
+                <a:latin typeface="Open Sans" pitchFamily="2" charset="0"/>
+                <a:ea typeface="Open Sans" pitchFamily="2" charset="0"/>
+                <a:cs typeface="Open Sans" pitchFamily="2" charset="0"/>
+              </a:rPr>
+              <a:t>A Simple Technique That Replaces Categories with Their </a:t>
+            </a:r>
+            <a:r>
+              <a:rPr lang="en-US" sz="3200">
+                <a:latin typeface="Open Sans" pitchFamily="2" charset="0"/>
+                <a:ea typeface="Open Sans" pitchFamily="2" charset="0"/>
+                <a:cs typeface="Open Sans" pitchFamily="2" charset="0"/>
+              </a:rPr>
+              <a:t>Occurrence Frequencies</a:t>
+            </a:r>
+            <a:endParaRPr lang="en-US" sz="3200" dirty="0">
+              <a:latin typeface="Open Sans" pitchFamily="2" charset="0"/>
+              <a:ea typeface="Open Sans" pitchFamily="2" charset="0"/>
+              <a:cs typeface="Open Sans" pitchFamily="2" charset="0"/>
+            </a:endParaRPr>
+          </a:p>
+        </p:txBody>
+      </p:sp>
+    </p:spTree>
+    <p:extLst>
+      <p:ext uri="{BB962C8B-B14F-4D97-AF65-F5344CB8AC3E}">
+        <p14:creationId xmlns:p14="http://schemas.microsoft.com/office/powerpoint/2010/main" val="3441164594"/>
+      </p:ext>
+    </p:extLst>
+  </p:cSld>
+  <p:clrMapOvr>
+    <a:masterClrMapping/>
+  </p:clrMapOvr>
+</p:sld>
+</file>
+
+<file path=ppt/slides/slide2.xml><?xml version="1.0" encoding="utf-8"?>
 <p:sld xmlns:a="http://schemas.openxmlformats.org/drawingml/2006/main" xmlns:r="http://schemas.openxmlformats.org/officeDocument/2006/relationships" xmlns:p="http://schemas.openxmlformats.org/presentationml/2006/main">
   <p:cSld>
     <p:spTree>
@@ -4203,7 +4313,7 @@
 </p:sld>
 </file>
 
-<file path=ppt/slides/slide2.xml><?xml version="1.0" encoding="utf-8"?>
+<file path=ppt/slides/slide3.xml><?xml version="1.0" encoding="utf-8"?>
 <p:sld xmlns:a="http://schemas.openxmlformats.org/drawingml/2006/main" xmlns:r="http://schemas.openxmlformats.org/officeDocument/2006/relationships" xmlns:p="http://schemas.openxmlformats.org/presentationml/2006/main">
   <p:cSld>
     <p:spTree>
@@ -4378,7 +4488,7 @@
 </p:sld>
 </file>
 
-<file path=ppt/slides/slide3.xml><?xml version="1.0" encoding="utf-8"?>
+<file path=ppt/slides/slide4.xml><?xml version="1.0" encoding="utf-8"?>
 <p:sld xmlns:a="http://schemas.openxmlformats.org/drawingml/2006/main" xmlns:r="http://schemas.openxmlformats.org/officeDocument/2006/relationships" xmlns:p="http://schemas.openxmlformats.org/presentationml/2006/main">
   <p:cSld>
     <p:spTree>
@@ -4606,7 +4716,7 @@
 </p:sld>
 </file>
 
-<file path=ppt/slides/slide4.xml><?xml version="1.0" encoding="utf-8"?>
+<file path=ppt/slides/slide5.xml><?xml version="1.0" encoding="utf-8"?>
 <p:sld xmlns:a="http://schemas.openxmlformats.org/drawingml/2006/main" xmlns:r="http://schemas.openxmlformats.org/officeDocument/2006/relationships" xmlns:p="http://schemas.openxmlformats.org/presentationml/2006/main">
   <p:cSld>
     <p:spTree>
@@ -5056,7 +5166,7 @@
 </p:sld>
 </file>
 
-<file path=ppt/slides/slide5.xml><?xml version="1.0" encoding="utf-8"?>
+<file path=ppt/slides/slide6.xml><?xml version="1.0" encoding="utf-8"?>
 <p:sld xmlns:a="http://schemas.openxmlformats.org/drawingml/2006/main" xmlns:r="http://schemas.openxmlformats.org/officeDocument/2006/relationships" xmlns:p="http://schemas.openxmlformats.org/presentationml/2006/main">
   <p:cSld>
     <p:spTree>
@@ -5308,7 +5418,7 @@
 </p:sld>
 </file>
 
-<file path=ppt/slides/slide6.xml><?xml version="1.0" encoding="utf-8"?>
+<file path=ppt/slides/slide7.xml><?xml version="1.0" encoding="utf-8"?>
 <p:sld xmlns:a="http://schemas.openxmlformats.org/drawingml/2006/main" xmlns:r="http://schemas.openxmlformats.org/officeDocument/2006/relationships" xmlns:p="http://schemas.openxmlformats.org/presentationml/2006/main">
   <p:cSld>
     <p:spTree>
@@ -5421,7 +5531,7 @@
 </p:sld>
 </file>
 
-<file path=ppt/slides/slide7.xml><?xml version="1.0" encoding="utf-8"?>
+<file path=ppt/slides/slide8.xml><?xml version="1.0" encoding="utf-8"?>
 <p:sld xmlns:a="http://schemas.openxmlformats.org/drawingml/2006/main" xmlns:r="http://schemas.openxmlformats.org/officeDocument/2006/relationships" xmlns:p="http://schemas.openxmlformats.org/presentationml/2006/main">
   <p:cSld>
     <p:spTree>

</xml_diff>